<commit_message>
Fix AI_SCM report time anchor: 2025 → 2026-03-24 현재 기준
- config.py: AS_OF_DATE="2026-03-24", CURRENT_YEAR=2026, CURRENT_YEAR_OFFSET=2
- CURRENT_CAPACITY_UTILIZATION: 2026 Q1 현실 반영
  HBM 95%→92%, CoWoS 92%→88%, Power_DC 78%→85%(2차 병목 부상), Networking 65%→78%
- HYPERSCALER_CAPEX: 2025=실적, 2026=현재가이던스, 2027=추정 구조로 재편
- GPU_SHIPMENTS: B200/GB200 2026 주력 출하 반영, H100 레거시 전환
- modeling_agent: current_snapshot year_offset=1→2 (2026 현재), 시나리오 2025~2028
- bottleneck_agent: 투자 윈도우 2026 현재 기준 업데이트
- data_agent: capacity_utilization을 seed_data 캐시 대신 config 직접 참조
- report_agent/word_agent: "2025 기준" → "2026년 Q1 현재" 레이블 전면 수정
- run.py: Key Findings에 현재 연도(2026) 동적 표시

Co-Authored-By: Claude Sonnet 4.6 <noreply@anthropic.com>
</commit_message>
<xml_diff>
--- a/AI_SCM/outputs/pptx/ai_scm_20260324.pptx
+++ b/AI_SCM/outputs/pptx/ai_scm_20260324.pptx
@@ -4973,7 +4973,7 @@
                   <a:srgbClr val="8FA3C0"/>
                 </a:solidFill>
               </a:rPr>
-              <a:t>Tokens/Day (2025 Base)</a:t>
+              <a:t>Tokens/Day (2026 현재 Base)</a:t>
             </a:r>
           </a:p>
         </p:txBody>
@@ -5007,7 +5007,7 @@
                   <a:srgbClr val="00BCD4"/>
                 </a:solidFill>
               </a:rPr>
-              <a:t>88.5T</a:t>
+              <a:t>328.8T</a:t>
             </a:r>
           </a:p>
         </p:txBody>
@@ -5120,7 +5120,7 @@
                   <a:srgbClr val="00BCD4"/>
                 </a:solidFill>
               </a:rPr>
-              <a:t>0.60M</a:t>
+              <a:t>2.24M</a:t>
             </a:r>
           </a:p>
         </p:txBody>
@@ -5233,7 +5233,7 @@
                   <a:srgbClr val="00BCD4"/>
                 </a:solidFill>
               </a:rPr>
-              <a:t>48.2PB</a:t>
+              <a:t>179.1PB</a:t>
             </a:r>
           </a:p>
         </p:txBody>
@@ -5346,7 +5346,7 @@
                   <a:srgbClr val="00BCD4"/>
                 </a:solidFill>
               </a:rPr>
-              <a:t>768MW</a:t>
+              <a:t>2851MW</a:t>
             </a:r>
           </a:p>
         </p:txBody>
@@ -6455,7 +6455,7 @@
                   <a:srgbClr val="F44336"/>
                 </a:solidFill>
               </a:rPr>
-              <a:t>Utilization: 95%</a:t>
+              <a:t>Utilization: 92%</a:t>
             </a:r>
           </a:p>
         </p:txBody>
@@ -6817,7 +6817,7 @@
                   <a:srgbClr val="FFEB3B"/>
                 </a:solidFill>
               </a:rPr>
-              <a:t>GPU</a:t>
+              <a:t>Power_DC</a:t>
             </a:r>
           </a:p>
         </p:txBody>
@@ -6851,7 +6851,7 @@
                   <a:srgbClr val="00BCD4"/>
                 </a:solidFill>
               </a:rPr>
-              <a:t>Component Utilization (2025)</a:t>
+              <a:t>레이어별 가동률 (2026년 Q1 현재)</a:t>
             </a:r>
           </a:p>
         </p:txBody>
@@ -6942,7 +6942,7 @@
         <p:spPr>
           <a:xfrm>
             <a:off x="274320" y="3502152"/>
-            <a:ext cx="2345436" cy="182880"/>
+            <a:ext cx="2271369" cy="182880"/>
           </a:xfrm>
           <a:prstGeom prst="rect">
             <a:avLst/>
@@ -7005,7 +7005,7 @@
                   <a:srgbClr val="F44336"/>
                 </a:solidFill>
               </a:rPr>
-              <a:t>95%</a:t>
+              <a:t>92%</a:t>
             </a:r>
           </a:p>
         </p:txBody>
@@ -7096,7 +7096,7 @@
         <p:spPr>
           <a:xfrm>
             <a:off x="3200400" y="3502152"/>
-            <a:ext cx="2271369" cy="182880"/>
+            <a:ext cx="2172614" cy="182880"/>
           </a:xfrm>
           <a:prstGeom prst="rect">
             <a:avLst/>
@@ -7159,7 +7159,7 @@
                   <a:srgbClr val="F44336"/>
                 </a:solidFill>
               </a:rPr>
-              <a:t>92%</a:t>
+              <a:t>88%</a:t>
             </a:r>
           </a:p>
         </p:txBody>
@@ -7193,7 +7193,7 @@
                   <a:srgbClr val="FFFFFF"/>
                 </a:solidFill>
               </a:rPr>
-              <a:t>GPU</a:t>
+              <a:t>Power_DC</a:t>
             </a:r>
           </a:p>
         </p:txBody>
@@ -7250,7 +7250,7 @@
         <p:spPr>
           <a:xfrm>
             <a:off x="6126480" y="3502152"/>
-            <a:ext cx="2172614" cy="182880"/>
+            <a:ext cx="2098548" cy="182880"/>
           </a:xfrm>
           <a:prstGeom prst="rect">
             <a:avLst/>
@@ -7313,7 +7313,7 @@
                   <a:srgbClr val="F44336"/>
                 </a:solidFill>
               </a:rPr>
-              <a:t>88%</a:t>
+              <a:t>85%</a:t>
             </a:r>
           </a:p>
         </p:txBody>
@@ -7347,7 +7347,7 @@
                   <a:srgbClr val="FFFFFF"/>
                 </a:solidFill>
               </a:rPr>
-              <a:t>Foundry_Advanced</a:t>
+              <a:t>Foundry</a:t>
             </a:r>
           </a:p>
         </p:txBody>
@@ -7404,7 +7404,7 @@
         <p:spPr>
           <a:xfrm>
             <a:off x="9052560" y="3502152"/>
-            <a:ext cx="2024481" cy="182880"/>
+            <a:ext cx="2073859" cy="182880"/>
           </a:xfrm>
           <a:prstGeom prst="rect">
             <a:avLst/>
@@ -7467,7 +7467,7 @@
                   <a:srgbClr val="FF9800"/>
                 </a:solidFill>
               </a:rPr>
-              <a:t>82%</a:t>
+              <a:t>84%</a:t>
             </a:r>
           </a:p>
         </p:txBody>
@@ -7501,7 +7501,7 @@
                   <a:srgbClr val="FFFFFF"/>
                 </a:solidFill>
               </a:rPr>
-              <a:t>Power_DC</a:t>
+              <a:t>GPU</a:t>
             </a:r>
           </a:p>
         </p:txBody>
@@ -7558,7 +7558,7 @@
         <p:spPr>
           <a:xfrm>
             <a:off x="274320" y="4279392"/>
-            <a:ext cx="1925726" cy="182880"/>
+            <a:ext cx="2024481" cy="182880"/>
           </a:xfrm>
           <a:prstGeom prst="rect">
             <a:avLst/>
@@ -7621,7 +7621,7 @@
                   <a:srgbClr val="FF9800"/>
                 </a:solidFill>
               </a:rPr>
-              <a:t>78%</a:t>
+              <a:t>82%</a:t>
             </a:r>
           </a:p>
         </p:txBody>
@@ -7655,7 +7655,7 @@
                   <a:srgbClr val="FFFFFF"/>
                 </a:solidFill>
               </a:rPr>
-              <a:t>ASIC</a:t>
+              <a:t>Networking</a:t>
             </a:r>
           </a:p>
         </p:txBody>
@@ -7712,7 +7712,7 @@
         <p:spPr>
           <a:xfrm>
             <a:off x="3200400" y="4279392"/>
-            <a:ext cx="1728216" cy="182880"/>
+            <a:ext cx="1925726" cy="182880"/>
           </a:xfrm>
           <a:prstGeom prst="rect">
             <a:avLst/>
@@ -7775,7 +7775,7 @@
                   <a:srgbClr val="FF9800"/>
                 </a:solidFill>
               </a:rPr>
-              <a:t>70%</a:t>
+              <a:t>78%</a:t>
             </a:r>
           </a:p>
         </p:txBody>
@@ -7809,7 +7809,7 @@
                   <a:srgbClr val="FFFFFF"/>
                 </a:solidFill>
               </a:rPr>
-              <a:t>Networking</a:t>
+              <a:t>ASIC</a:t>
             </a:r>
           </a:p>
         </p:txBody>
@@ -7866,7 +7866,161 @@
         <p:spPr>
           <a:xfrm>
             <a:off x="6126480" y="4279392"/>
-            <a:ext cx="1604772" cy="182880"/>
+            <a:ext cx="1925726" cy="182880"/>
+          </a:xfrm>
+          <a:prstGeom prst="rect">
+            <a:avLst/>
+          </a:prstGeom>
+          <a:solidFill>
+            <a:srgbClr val="FF9800"/>
+          </a:solidFill>
+          <a:ln>
+            <a:noFill/>
+          </a:ln>
+        </p:spPr>
+        <p:style>
+          <a:lnRef idx="1">
+            <a:schemeClr val="accent1"/>
+          </a:lnRef>
+          <a:fillRef idx="3">
+            <a:schemeClr val="accent1"/>
+          </a:fillRef>
+          <a:effectRef idx="2">
+            <a:schemeClr val="accent1"/>
+          </a:effectRef>
+          <a:fontRef idx="minor">
+            <a:schemeClr val="lt1"/>
+          </a:fontRef>
+        </p:style>
+        <p:txBody>
+          <a:bodyPr rtlCol="0" anchor="ctr"/>
+          <a:lstStyle/>
+          <a:p>
+            <a:pPr algn="ctr"/>
+          </a:p>
+        </p:txBody>
+      </p:sp>
+      <p:sp>
+        <p:nvSpPr>
+          <p:cNvPr id="46" name="TextBox 45"/>
+          <p:cNvSpPr txBox="1"/>
+          <p:nvPr/>
+        </p:nvSpPr>
+        <p:spPr>
+          <a:xfrm>
+            <a:off x="8641080" y="4242816"/>
+            <a:ext cx="457200" cy="274320"/>
+          </a:xfrm>
+          <a:prstGeom prst="rect">
+            <a:avLst/>
+          </a:prstGeom>
+          <a:noFill/>
+        </p:spPr>
+        <p:txBody>
+          <a:bodyPr wrap="square">
+            <a:spAutoFit/>
+          </a:bodyPr>
+          <a:lstStyle/>
+          <a:p>
+            <a:pPr algn="l"/>
+            <a:r>
+              <a:rPr sz="1000" b="1">
+                <a:solidFill>
+                  <a:srgbClr val="FF9800"/>
+                </a:solidFill>
+              </a:rPr>
+              <a:t>78%</a:t>
+            </a:r>
+          </a:p>
+        </p:txBody>
+      </p:sp>
+      <p:sp>
+        <p:nvSpPr>
+          <p:cNvPr id="47" name="TextBox 46"/>
+          <p:cNvSpPr txBox="1"/>
+          <p:nvPr/>
+        </p:nvSpPr>
+        <p:spPr>
+          <a:xfrm>
+            <a:off x="9052560" y="4023359"/>
+            <a:ext cx="2743200" cy="228600"/>
+          </a:xfrm>
+          <a:prstGeom prst="rect">
+            <a:avLst/>
+          </a:prstGeom>
+          <a:noFill/>
+        </p:spPr>
+        <p:txBody>
+          <a:bodyPr wrap="square">
+            <a:spAutoFit/>
+          </a:bodyPr>
+          <a:lstStyle/>
+          <a:p>
+            <a:pPr algn="l"/>
+            <a:r>
+              <a:rPr sz="1000" b="1">
+                <a:solidFill>
+                  <a:srgbClr val="FFFFFF"/>
+                </a:solidFill>
+              </a:rPr>
+              <a:t>DRAM</a:t>
+            </a:r>
+          </a:p>
+        </p:txBody>
+      </p:sp>
+      <p:sp>
+        <p:nvSpPr>
+          <p:cNvPr id="48" name="Rectangle 47"/>
+          <p:cNvSpPr/>
+          <p:nvPr/>
+        </p:nvSpPr>
+        <p:spPr>
+          <a:xfrm>
+            <a:off x="9052560" y="4279392"/>
+            <a:ext cx="2468880" cy="182880"/>
+          </a:xfrm>
+          <a:prstGeom prst="rect">
+            <a:avLst/>
+          </a:prstGeom>
+          <a:solidFill>
+            <a:srgbClr val="1E3A5F"/>
+          </a:solidFill>
+          <a:ln>
+            <a:noFill/>
+          </a:ln>
+        </p:spPr>
+        <p:style>
+          <a:lnRef idx="1">
+            <a:schemeClr val="accent1"/>
+          </a:lnRef>
+          <a:fillRef idx="3">
+            <a:schemeClr val="accent1"/>
+          </a:fillRef>
+          <a:effectRef idx="2">
+            <a:schemeClr val="accent1"/>
+          </a:effectRef>
+          <a:fontRef idx="minor">
+            <a:schemeClr val="lt1"/>
+          </a:fontRef>
+        </p:style>
+        <p:txBody>
+          <a:bodyPr rtlCol="0" anchor="ctr"/>
+          <a:lstStyle/>
+          <a:p>
+            <a:pPr algn="ctr"/>
+          </a:p>
+        </p:txBody>
+      </p:sp>
+      <p:sp>
+        <p:nvSpPr>
+          <p:cNvPr id="49" name="Rectangle 48"/>
+          <p:cNvSpPr/>
+          <p:nvPr/>
+        </p:nvSpPr>
+        <p:spPr>
+          <a:xfrm>
+            <a:off x="9052560" y="4279392"/>
+            <a:ext cx="1530705" cy="182880"/>
           </a:xfrm>
           <a:prstGeom prst="rect">
             <a:avLst/>
@@ -7902,160 +8056,6 @@
       </p:sp>
       <p:sp>
         <p:nvSpPr>
-          <p:cNvPr id="46" name="TextBox 45"/>
-          <p:cNvSpPr txBox="1"/>
-          <p:nvPr/>
-        </p:nvSpPr>
-        <p:spPr>
-          <a:xfrm>
-            <a:off x="8641080" y="4242816"/>
-            <a:ext cx="457200" cy="274320"/>
-          </a:xfrm>
-          <a:prstGeom prst="rect">
-            <a:avLst/>
-          </a:prstGeom>
-          <a:noFill/>
-        </p:spPr>
-        <p:txBody>
-          <a:bodyPr wrap="square">
-            <a:spAutoFit/>
-          </a:bodyPr>
-          <a:lstStyle/>
-          <a:p>
-            <a:pPr algn="l"/>
-            <a:r>
-              <a:rPr sz="1000" b="1">
-                <a:solidFill>
-                  <a:srgbClr val="FFEB3B"/>
-                </a:solidFill>
-              </a:rPr>
-              <a:t>65%</a:t>
-            </a:r>
-          </a:p>
-        </p:txBody>
-      </p:sp>
-      <p:sp>
-        <p:nvSpPr>
-          <p:cNvPr id="47" name="TextBox 46"/>
-          <p:cNvSpPr txBox="1"/>
-          <p:nvPr/>
-        </p:nvSpPr>
-        <p:spPr>
-          <a:xfrm>
-            <a:off x="9052560" y="4023359"/>
-            <a:ext cx="2743200" cy="228600"/>
-          </a:xfrm>
-          <a:prstGeom prst="rect">
-            <a:avLst/>
-          </a:prstGeom>
-          <a:noFill/>
-        </p:spPr>
-        <p:txBody>
-          <a:bodyPr wrap="square">
-            <a:spAutoFit/>
-          </a:bodyPr>
-          <a:lstStyle/>
-          <a:p>
-            <a:pPr algn="l"/>
-            <a:r>
-              <a:rPr sz="1000" b="1">
-                <a:solidFill>
-                  <a:srgbClr val="FFFFFF"/>
-                </a:solidFill>
-              </a:rPr>
-              <a:t>DRAM</a:t>
-            </a:r>
-          </a:p>
-        </p:txBody>
-      </p:sp>
-      <p:sp>
-        <p:nvSpPr>
-          <p:cNvPr id="48" name="Rectangle 47"/>
-          <p:cNvSpPr/>
-          <p:nvPr/>
-        </p:nvSpPr>
-        <p:spPr>
-          <a:xfrm>
-            <a:off x="9052560" y="4279392"/>
-            <a:ext cx="2468880" cy="182880"/>
-          </a:xfrm>
-          <a:prstGeom prst="rect">
-            <a:avLst/>
-          </a:prstGeom>
-          <a:solidFill>
-            <a:srgbClr val="1E3A5F"/>
-          </a:solidFill>
-          <a:ln>
-            <a:noFill/>
-          </a:ln>
-        </p:spPr>
-        <p:style>
-          <a:lnRef idx="1">
-            <a:schemeClr val="accent1"/>
-          </a:lnRef>
-          <a:fillRef idx="3">
-            <a:schemeClr val="accent1"/>
-          </a:fillRef>
-          <a:effectRef idx="2">
-            <a:schemeClr val="accent1"/>
-          </a:effectRef>
-          <a:fontRef idx="minor">
-            <a:schemeClr val="lt1"/>
-          </a:fontRef>
-        </p:style>
-        <p:txBody>
-          <a:bodyPr rtlCol="0" anchor="ctr"/>
-          <a:lstStyle/>
-          <a:p>
-            <a:pPr algn="ctr"/>
-          </a:p>
-        </p:txBody>
-      </p:sp>
-      <p:sp>
-        <p:nvSpPr>
-          <p:cNvPr id="49" name="Rectangle 48"/>
-          <p:cNvSpPr/>
-          <p:nvPr/>
-        </p:nvSpPr>
-        <p:spPr>
-          <a:xfrm>
-            <a:off x="9052560" y="4279392"/>
-            <a:ext cx="1357884" cy="182880"/>
-          </a:xfrm>
-          <a:prstGeom prst="rect">
-            <a:avLst/>
-          </a:prstGeom>
-          <a:solidFill>
-            <a:srgbClr val="FFEB3B"/>
-          </a:solidFill>
-          <a:ln>
-            <a:noFill/>
-          </a:ln>
-        </p:spPr>
-        <p:style>
-          <a:lnRef idx="1">
-            <a:schemeClr val="accent1"/>
-          </a:lnRef>
-          <a:fillRef idx="3">
-            <a:schemeClr val="accent1"/>
-          </a:fillRef>
-          <a:effectRef idx="2">
-            <a:schemeClr val="accent1"/>
-          </a:effectRef>
-          <a:fontRef idx="minor">
-            <a:schemeClr val="lt1"/>
-          </a:fontRef>
-        </p:style>
-        <p:txBody>
-          <a:bodyPr rtlCol="0" anchor="ctr"/>
-          <a:lstStyle/>
-          <a:p>
-            <a:pPr algn="ctr"/>
-          </a:p>
-        </p:txBody>
-      </p:sp>
-      <p:sp>
-        <p:nvSpPr>
           <p:cNvPr id="50" name="TextBox 49"/>
           <p:cNvSpPr txBox="1"/>
           <p:nvPr/>
@@ -8083,7 +8083,7 @@
                   <a:srgbClr val="FFEB3B"/>
                 </a:solidFill>
               </a:rPr>
-              <a:t>55%</a:t>
+              <a:t>62%</a:t>
             </a:r>
           </a:p>
         </p:txBody>
@@ -8433,7 +8433,7 @@
                   <a:srgbClr val="FFFFFF"/>
                 </a:solidFill>
               </a:rPr>
-              <a:t>2026E</a:t>
+              <a:t>2026</a:t>
             </a:r>
           </a:p>
         </p:txBody>
@@ -8705,7 +8705,7 @@
                   <a:srgbClr val="00E676"/>
                 </a:solidFill>
               </a:rPr>
-              <a:t>+40%</a:t>
+              <a:t>+33%</a:t>
             </a:r>
           </a:p>
         </p:txBody>
@@ -8909,7 +8909,7 @@
                   <a:srgbClr val="00A4EF"/>
                 </a:solidFill>
               </a:rPr>
-              <a:t>$90B</a:t>
+              <a:t>$95B</a:t>
             </a:r>
           </a:p>
         </p:txBody>
@@ -8943,7 +8943,7 @@
                   <a:srgbClr val="00E676"/>
                 </a:solidFill>
               </a:rPr>
-              <a:t>+54%</a:t>
+              <a:t>+44%</a:t>
             </a:r>
           </a:p>
         </p:txBody>
@@ -9147,7 +9147,7 @@
                   <a:srgbClr val="4285F4"/>
                 </a:solidFill>
               </a:rPr>
-              <a:t>$85B</a:t>
+              <a:t>$90B</a:t>
             </a:r>
           </a:p>
         </p:txBody>
@@ -9181,7 +9181,7 @@
                   <a:srgbClr val="00E676"/>
                 </a:solidFill>
               </a:rPr>
-              <a:t>+44%</a:t>
+              <a:t>+38%</a:t>
             </a:r>
           </a:p>
         </p:txBody>
@@ -9419,7 +9419,7 @@
                   <a:srgbClr val="00E676"/>
                 </a:solidFill>
               </a:rPr>
-              <a:t>+28%</a:t>
+              <a:t>+23%</a:t>
             </a:r>
           </a:p>
         </p:txBody>
@@ -9623,7 +9623,7 @@
                   <a:srgbClr val="FFFFFF"/>
                 </a:solidFill>
               </a:rPr>
-              <a:t>$25B</a:t>
+              <a:t>$30B</a:t>
             </a:r>
           </a:p>
         </p:txBody>
@@ -9904,7 +9904,7 @@
                   <a:srgbClr val="00BCD4"/>
                 </a:solidFill>
               </a:rPr>
-              <a:t>$392B</a:t>
+              <a:t>$407B</a:t>
             </a:r>
           </a:p>
         </p:txBody>
@@ -9938,7 +9938,7 @@
                   <a:srgbClr val="8FA3C0"/>
                 </a:solidFill>
               </a:rPr>
-              <a:t>Big 5 combined CapEx: $154B (2022) → $340B (2025) → $392B (2026E)  |  AI infrastructure is now the largest single CapEx category in tech history</a:t>
+              <a:t>Big 5 합산 CapEx: $154B (2022) → $340B (2025실적) → $407B (2026가이던스)  |  AI infrastructure is now the largest single CapEx category in tech history</a:t>
             </a:r>
           </a:p>
         </p:txBody>
@@ -10594,7 +10594,7 @@
                   <a:srgbClr val="8FA3C0"/>
                 </a:solidFill>
               </a:rPr>
-              <a:t>CoWoS at 92% utilization (critical bottleneck)</a:t>
+              <a:t>CoWoS at 88% utilization (critical bottleneck)</a:t>
             </a:r>
           </a:p>
         </p:txBody>
@@ -10764,7 +10764,7 @@
                   <a:srgbClr val="8FA3C0"/>
                 </a:solidFill>
               </a:rPr>
-              <a:t>CoWoS at 92% utilization (critical bottleneck)</a:t>
+              <a:t>CoWoS at 88% utilization (critical bottleneck)</a:t>
             </a:r>
           </a:p>
         </p:txBody>
@@ -10934,7 +10934,7 @@
                   <a:srgbClr val="8FA3C0"/>
                 </a:solidFill>
               </a:rPr>
-              <a:t>CoWoS at 92% utilization (critical bottleneck)</a:t>
+              <a:t>CoWoS at 88% utilization (critical bottleneck)</a:t>
             </a:r>
           </a:p>
         </p:txBody>
@@ -11002,7 +11002,7 @@
                   <a:srgbClr val="FFFFFF"/>
                 </a:solidFill>
               </a:rPr>
-              <a:t>Micron</a:t>
+              <a:t>Vertiv</a:t>
             </a:r>
           </a:p>
         </p:txBody>
@@ -11036,7 +11036,7 @@
                   <a:srgbClr val="8FA3C0"/>
                 </a:solidFill>
               </a:rPr>
-              <a:t>HBM</a:t>
+              <a:t>Power_DC</a:t>
             </a:r>
           </a:p>
         </p:txBody>
@@ -11067,10 +11067,10 @@
             <a:r>
               <a:rPr sz="900" b="1">
                 <a:solidFill>
-                  <a:srgbClr val="4CAF50"/>
-                </a:solidFill>
-              </a:rPr>
-              <a:t>Buy</a:t>
+                  <a:srgbClr val="00E676"/>
+                </a:solidFill>
+              </a:rPr>
+              <a:t>Strong Buy</a:t>
             </a:r>
           </a:p>
         </p:txBody>
@@ -11104,7 +11104,7 @@
                   <a:srgbClr val="8FA3C0"/>
                 </a:solidFill>
               </a:rPr>
-              <a:t>HBM3e market share gain 10% -&gt; 20%+; CHIPS Act domestic fab beneficiary; NVIDIA supply div...</a:t>
+              <a:t>Power_DC at 85% utilization (critical bottleneck)</a:t>
             </a:r>
           </a:p>
         </p:txBody>
@@ -11138,7 +11138,7 @@
                   <a:srgbClr val="8FA3C0"/>
                 </a:solidFill>
               </a:rPr>
-              <a:t>12-24 months</a:t>
+              <a:t>0-24 months</a:t>
             </a:r>
           </a:p>
         </p:txBody>
@@ -11172,7 +11172,7 @@
                   <a:srgbClr val="FFFFFF"/>
                 </a:solidFill>
               </a:rPr>
-              <a:t>TSMC</a:t>
+              <a:t>Eaton</a:t>
             </a:r>
           </a:p>
         </p:txBody>
@@ -11206,7 +11206,7 @@
                   <a:srgbClr val="8FA3C0"/>
                 </a:solidFill>
               </a:rPr>
-              <a:t>Packaging/Foundry</a:t>
+              <a:t>Power_DC</a:t>
             </a:r>
           </a:p>
         </p:txBody>
@@ -11237,10 +11237,10 @@
             <a:r>
               <a:rPr sz="900" b="1">
                 <a:solidFill>
-                  <a:srgbClr val="4CAF50"/>
-                </a:solidFill>
-              </a:rPr>
-              <a:t>Buy</a:t>
+                  <a:srgbClr val="00E676"/>
+                </a:solidFill>
+              </a:rPr>
+              <a:t>Strong Buy</a:t>
             </a:r>
           </a:p>
         </p:txBody>
@@ -11274,7 +11274,7 @@
                   <a:srgbClr val="8FA3C0"/>
                 </a:solidFill>
               </a:rPr>
-              <a:t>CoWoS monopoly for AI packaging (92% util); N3/N2 pricing power; AI chips 20%+ of revenue</a:t>
+              <a:t>Power_DC at 85% utilization (critical bottleneck)</a:t>
             </a:r>
           </a:p>
         </p:txBody>
@@ -11308,7 +11308,7 @@
                   <a:srgbClr val="8FA3C0"/>
                 </a:solidFill>
               </a:rPr>
-              <a:t>12-36 months</a:t>
+              <a:t>0-24 months</a:t>
             </a:r>
           </a:p>
         </p:txBody>
@@ -11342,7 +11342,7 @@
                   <a:srgbClr val="FFFFFF"/>
                 </a:solidFill>
               </a:rPr>
-              <a:t>Vertiv</a:t>
+              <a:t>Schneider Electric</a:t>
             </a:r>
           </a:p>
         </p:txBody>
@@ -11376,7 +11376,7 @@
                   <a:srgbClr val="8FA3C0"/>
                 </a:solidFill>
               </a:rPr>
-              <a:t>Power</a:t>
+              <a:t>Power_DC</a:t>
             </a:r>
           </a:p>
         </p:txBody>
@@ -11407,10 +11407,10 @@
             <a:r>
               <a:rPr sz="900" b="1">
                 <a:solidFill>
-                  <a:srgbClr val="4CAF50"/>
-                </a:solidFill>
-              </a:rPr>
-              <a:t>Buy</a:t>
+                  <a:srgbClr val="00E676"/>
+                </a:solidFill>
+              </a:rPr>
+              <a:t>Strong Buy</a:t>
             </a:r>
           </a:p>
         </p:txBody>
@@ -11444,7 +11444,7 @@
                   <a:srgbClr val="8FA3C0"/>
                 </a:solidFill>
               </a:rPr>
-              <a:t>DC power infrastructure bottleneck; sold out through 2026; AI-driven thermal mgmt demand</a:t>
+              <a:t>Power_DC at 85% utilization (critical bottleneck)</a:t>
             </a:r>
           </a:p>
         </p:txBody>
@@ -11478,7 +11478,7 @@
                   <a:srgbClr val="8FA3C0"/>
                 </a:solidFill>
               </a:rPr>
-              <a:t>6-18 months</a:t>
+              <a:t>0-24 months</a:t>
             </a:r>
           </a:p>
         </p:txBody>
@@ -11512,7 +11512,7 @@
                   <a:srgbClr val="FFFFFF"/>
                 </a:solidFill>
               </a:rPr>
-              <a:t>GE Vernova</a:t>
+              <a:t>Micron</a:t>
             </a:r>
           </a:p>
         </p:txBody>
@@ -11546,7 +11546,7 @@
                   <a:srgbClr val="8FA3C0"/>
                 </a:solidFill>
               </a:rPr>
-              <a:t>Power</a:t>
+              <a:t>HBM</a:t>
             </a:r>
           </a:p>
         </p:txBody>
@@ -11614,7 +11614,7 @@
                   <a:srgbClr val="8FA3C0"/>
                 </a:solidFill>
               </a:rPr>
-              <a:t>Gas turbine + grid equipment; transformer shortage 30mo lead time; nuclear AI data center ...</a:t>
+              <a:t>HBM3e market share gain 10% -&gt; 20%+; CHIPS Act domestic fab beneficiary; NVIDIA supply div...</a:t>
             </a:r>
           </a:p>
         </p:txBody>
@@ -12736,7 +12736,7 @@
                   <a:srgbClr val="FFFFFF"/>
                 </a:solidFill>
               </a:rPr>
-              <a:t>2025-2027 AI Demand Forecast Scenarios</a:t>
+              <a:t>2026-2028 AI 수요 예측 시나리오 (기준일: 2026-03-24)</a:t>
             </a:r>
           </a:p>
         </p:txBody>
@@ -12881,7 +12881,7 @@
                   <a:srgbClr val="FFFFFF"/>
                 </a:solidFill>
               </a:rPr>
-              <a:t>2024</a:t>
+              <a:t>2025</a:t>
             </a:r>
           </a:p>
         </p:txBody>
@@ -12915,7 +12915,7 @@
                   <a:srgbClr val="FFFFFF"/>
                 </a:solidFill>
               </a:rPr>
-              <a:t>2025</a:t>
+              <a:t>2026</a:t>
             </a:r>
           </a:p>
         </p:txBody>
@@ -12949,7 +12949,7 @@
                   <a:srgbClr val="FFFFFF"/>
                 </a:solidFill>
               </a:rPr>
-              <a:t>2026</a:t>
+              <a:t>2027</a:t>
             </a:r>
           </a:p>
         </p:txBody>
@@ -12983,7 +12983,7 @@
                   <a:srgbClr val="FFFFFF"/>
                 </a:solidFill>
               </a:rPr>
-              <a:t>2027</a:t>
+              <a:t>2028</a:t>
             </a:r>
           </a:p>
         </p:txBody>
@@ -13085,7 +13085,7 @@
                   <a:srgbClr val="F44336"/>
                 </a:solidFill>
               </a:rPr>
-              <a:t>25.0T</a:t>
+              <a:t>62.0T</a:t>
             </a:r>
           </a:p>
         </p:txBody>
@@ -13119,7 +13119,7 @@
                   <a:srgbClr val="F44336"/>
                 </a:solidFill>
               </a:rPr>
-              <a:t>62.0T</a:t>
+              <a:t>161.1T</a:t>
             </a:r>
           </a:p>
         </p:txBody>
@@ -13153,7 +13153,7 @@
                   <a:srgbClr val="F44336"/>
                 </a:solidFill>
               </a:rPr>
-              <a:t>161.1T</a:t>
+              <a:t>441.3T</a:t>
             </a:r>
           </a:p>
         </p:txBody>
@@ -13187,7 +13187,7 @@
                   <a:srgbClr val="F44336"/>
                 </a:solidFill>
               </a:rPr>
-              <a:t>441.3T</a:t>
+              <a:t>1273.1T</a:t>
             </a:r>
           </a:p>
         </p:txBody>
@@ -13255,7 +13255,7 @@
                   <a:srgbClr val="F44336"/>
                 </a:solidFill>
               </a:rPr>
-              <a:t>0.17M</a:t>
+              <a:t>0.42M</a:t>
             </a:r>
           </a:p>
         </p:txBody>
@@ -13289,7 +13289,7 @@
                   <a:srgbClr val="F44336"/>
                 </a:solidFill>
               </a:rPr>
-              <a:t>0.42M</a:t>
+              <a:t>1.10M</a:t>
             </a:r>
           </a:p>
         </p:txBody>
@@ -13323,7 +13323,7 @@
                   <a:srgbClr val="F44336"/>
                 </a:solidFill>
               </a:rPr>
-              <a:t>1.10M</a:t>
+              <a:t>3.00M</a:t>
             </a:r>
           </a:p>
         </p:txBody>
@@ -13357,7 +13357,7 @@
                   <a:srgbClr val="F44336"/>
                 </a:solidFill>
               </a:rPr>
-              <a:t>3.00M</a:t>
+              <a:t>8.67M</a:t>
             </a:r>
           </a:p>
         </p:txBody>
@@ -13425,7 +13425,7 @@
                   <a:srgbClr val="F44336"/>
                 </a:solidFill>
               </a:rPr>
-              <a:t>13.6PB</a:t>
+              <a:t>33.7PB</a:t>
             </a:r>
           </a:p>
         </p:txBody>
@@ -13459,7 +13459,7 @@
                   <a:srgbClr val="F44336"/>
                 </a:solidFill>
               </a:rPr>
-              <a:t>33.7PB</a:t>
+              <a:t>87.7PB</a:t>
             </a:r>
           </a:p>
         </p:txBody>
@@ -13493,7 +13493,7 @@
                   <a:srgbClr val="F44336"/>
                 </a:solidFill>
               </a:rPr>
-              <a:t>87.7PB</a:t>
+              <a:t>240.4PB</a:t>
             </a:r>
           </a:p>
         </p:txBody>
@@ -13527,7 +13527,7 @@
                   <a:srgbClr val="F44336"/>
                 </a:solidFill>
               </a:rPr>
-              <a:t>240.4PB</a:t>
+              <a:t>693.4PB</a:t>
             </a:r>
           </a:p>
         </p:txBody>
@@ -13595,7 +13595,7 @@
                   <a:srgbClr val="F44336"/>
                 </a:solidFill>
               </a:rPr>
-              <a:t>217MW</a:t>
+              <a:t>537MW</a:t>
             </a:r>
           </a:p>
         </p:txBody>
@@ -13629,7 +13629,7 @@
                   <a:srgbClr val="F44336"/>
                 </a:solidFill>
               </a:rPr>
-              <a:t>537MW</a:t>
+              <a:t>1397MW</a:t>
             </a:r>
           </a:p>
         </p:txBody>
@@ -13663,7 +13663,7 @@
                   <a:srgbClr val="F44336"/>
                 </a:solidFill>
               </a:rPr>
-              <a:t>1397MW</a:t>
+              <a:t>3828MW</a:t>
             </a:r>
           </a:p>
         </p:txBody>
@@ -13697,7 +13697,7 @@
                   <a:srgbClr val="F44336"/>
                 </a:solidFill>
               </a:rPr>
-              <a:t>3828MW</a:t>
+              <a:t>11042MW</a:t>
             </a:r>
           </a:p>
         </p:txBody>
@@ -13799,7 +13799,7 @@
                   <a:srgbClr val="1E88E5"/>
                 </a:solidFill>
               </a:rPr>
-              <a:t>25.0T</a:t>
+              <a:t>88.5T</a:t>
             </a:r>
           </a:p>
         </p:txBody>
@@ -13833,7 +13833,7 @@
                   <a:srgbClr val="1E88E5"/>
                 </a:solidFill>
               </a:rPr>
-              <a:t>88.5T</a:t>
+              <a:t>328.8T</a:t>
             </a:r>
           </a:p>
         </p:txBody>
@@ -13867,7 +13867,7 @@
                   <a:srgbClr val="1E88E5"/>
                 </a:solidFill>
               </a:rPr>
-              <a:t>328.8T</a:t>
+              <a:t>1286.6T</a:t>
             </a:r>
           </a:p>
         </p:txBody>
@@ -13901,7 +13901,7 @@
                   <a:srgbClr val="1E88E5"/>
                 </a:solidFill>
               </a:rPr>
-              <a:t>1286.6T</a:t>
+              <a:t>5302.2T</a:t>
             </a:r>
           </a:p>
         </p:txBody>
@@ -13969,7 +13969,7 @@
                   <a:srgbClr val="1E88E5"/>
                 </a:solidFill>
               </a:rPr>
-              <a:t>0.17M</a:t>
+              <a:t>0.60M</a:t>
             </a:r>
           </a:p>
         </p:txBody>
@@ -14003,7 +14003,7 @@
                   <a:srgbClr val="1E88E5"/>
                 </a:solidFill>
               </a:rPr>
-              <a:t>0.60M</a:t>
+              <a:t>2.24M</a:t>
             </a:r>
           </a:p>
         </p:txBody>
@@ -14037,7 +14037,7 @@
                   <a:srgbClr val="1E88E5"/>
                 </a:solidFill>
               </a:rPr>
-              <a:t>2.24M</a:t>
+              <a:t>8.76M</a:t>
             </a:r>
           </a:p>
         </p:txBody>
@@ -14071,7 +14071,7 @@
                   <a:srgbClr val="1E88E5"/>
                 </a:solidFill>
               </a:rPr>
-              <a:t>8.76M</a:t>
+              <a:t>36.10M</a:t>
             </a:r>
           </a:p>
         </p:txBody>
@@ -14139,7 +14139,7 @@
                   <a:srgbClr val="1E88E5"/>
                 </a:solidFill>
               </a:rPr>
-              <a:t>13.6PB</a:t>
+              <a:t>48.2PB</a:t>
             </a:r>
           </a:p>
         </p:txBody>
@@ -14173,7 +14173,7 @@
                   <a:srgbClr val="1E88E5"/>
                 </a:solidFill>
               </a:rPr>
-              <a:t>48.2PB</a:t>
+              <a:t>179.1PB</a:t>
             </a:r>
           </a:p>
         </p:txBody>
@@ -14207,7 +14207,7 @@
                   <a:srgbClr val="1E88E5"/>
                 </a:solidFill>
               </a:rPr>
-              <a:t>179.1PB</a:t>
+              <a:t>700.8PB</a:t>
             </a:r>
           </a:p>
         </p:txBody>
@@ -14241,7 +14241,7 @@
                   <a:srgbClr val="1E88E5"/>
                 </a:solidFill>
               </a:rPr>
-              <a:t>700.8PB</a:t>
+              <a:t>2887.9PB</a:t>
             </a:r>
           </a:p>
         </p:txBody>
@@ -14309,7 +14309,7 @@
                   <a:srgbClr val="1E88E5"/>
                 </a:solidFill>
               </a:rPr>
-              <a:t>217MW</a:t>
+              <a:t>768MW</a:t>
             </a:r>
           </a:p>
         </p:txBody>
@@ -14343,7 +14343,7 @@
                   <a:srgbClr val="1E88E5"/>
                 </a:solidFill>
               </a:rPr>
-              <a:t>768MW</a:t>
+              <a:t>2851MW</a:t>
             </a:r>
           </a:p>
         </p:txBody>
@@ -14377,7 +14377,7 @@
                   <a:srgbClr val="1E88E5"/>
                 </a:solidFill>
               </a:rPr>
-              <a:t>2851MW</a:t>
+              <a:t>11160MW</a:t>
             </a:r>
           </a:p>
         </p:txBody>
@@ -14411,7 +14411,7 @@
                   <a:srgbClr val="1E88E5"/>
                 </a:solidFill>
               </a:rPr>
-              <a:t>11160MW</a:t>
+              <a:t>45990MW</a:t>
             </a:r>
           </a:p>
         </p:txBody>
@@ -14513,7 +14513,7 @@
                   <a:srgbClr val="00E676"/>
                 </a:solidFill>
               </a:rPr>
-              <a:t>25.0T</a:t>
+              <a:t>132.8T</a:t>
             </a:r>
           </a:p>
         </p:txBody>
@@ -14547,7 +14547,7 @@
                   <a:srgbClr val="00E676"/>
                 </a:solidFill>
               </a:rPr>
-              <a:t>132.8T</a:t>
+              <a:t>739.7T</a:t>
             </a:r>
           </a:p>
         </p:txBody>
@@ -14581,7 +14581,7 @@
                   <a:srgbClr val="00E676"/>
                 </a:solidFill>
               </a:rPr>
-              <a:t>739.7T</a:t>
+              <a:t>4342.4T</a:t>
             </a:r>
           </a:p>
         </p:txBody>
@@ -14615,7 +14615,7 @@
                   <a:srgbClr val="00E676"/>
                 </a:solidFill>
               </a:rPr>
-              <a:t>4342.4T</a:t>
+              <a:t>26842.3T</a:t>
             </a:r>
           </a:p>
         </p:txBody>
@@ -14683,7 +14683,7 @@
                   <a:srgbClr val="00E676"/>
                 </a:solidFill>
               </a:rPr>
-              <a:t>0.17M</a:t>
+              <a:t>0.90M</a:t>
             </a:r>
           </a:p>
         </p:txBody>
@@ -14717,7 +14717,7 @@
                   <a:srgbClr val="00E676"/>
                 </a:solidFill>
               </a:rPr>
-              <a:t>0.90M</a:t>
+              <a:t>5.04M</a:t>
             </a:r>
           </a:p>
         </p:txBody>
@@ -14751,7 +14751,7 @@
                   <a:srgbClr val="00E676"/>
                 </a:solidFill>
               </a:rPr>
-              <a:t>5.04M</a:t>
+              <a:t>29.56M</a:t>
             </a:r>
           </a:p>
         </p:txBody>
@@ -14785,7 +14785,7 @@
                   <a:srgbClr val="00E676"/>
                 </a:solidFill>
               </a:rPr>
-              <a:t>29.56M</a:t>
+              <a:t>182.75M</a:t>
             </a:r>
           </a:p>
         </p:txBody>
@@ -14853,7 +14853,7 @@
                   <a:srgbClr val="00E676"/>
                 </a:solidFill>
               </a:rPr>
-              <a:t>13.6PB</a:t>
+              <a:t>72.3PB</a:t>
             </a:r>
           </a:p>
         </p:txBody>
@@ -14887,7 +14887,7 @@
                   <a:srgbClr val="00E676"/>
                 </a:solidFill>
               </a:rPr>
-              <a:t>72.3PB</a:t>
+              <a:t>402.9PB</a:t>
             </a:r>
           </a:p>
         </p:txBody>
@@ -14921,7 +14921,7 @@
                   <a:srgbClr val="00E676"/>
                 </a:solidFill>
               </a:rPr>
-              <a:t>402.9PB</a:t>
+              <a:t>2365.1PB</a:t>
             </a:r>
           </a:p>
         </p:txBody>
@@ -14955,7 +14955,7 @@
                   <a:srgbClr val="00E676"/>
                 </a:solidFill>
               </a:rPr>
-              <a:t>2365.1PB</a:t>
+              <a:t>14620.0PB</a:t>
             </a:r>
           </a:p>
         </p:txBody>
@@ -15023,7 +15023,7 @@
                   <a:srgbClr val="00E676"/>
                 </a:solidFill>
               </a:rPr>
-              <a:t>217MW</a:t>
+              <a:t>1151MW</a:t>
             </a:r>
           </a:p>
         </p:txBody>
@@ -15057,7 +15057,7 @@
                   <a:srgbClr val="00E676"/>
                 </a:solidFill>
               </a:rPr>
-              <a:t>1151MW</a:t>
+              <a:t>6416MW</a:t>
             </a:r>
           </a:p>
         </p:txBody>
@@ -15091,7 +15091,7 @@
                   <a:srgbClr val="00E676"/>
                 </a:solidFill>
               </a:rPr>
-              <a:t>6416MW</a:t>
+              <a:t>37665MW</a:t>
             </a:r>
           </a:p>
         </p:txBody>
@@ -15125,7 +15125,7 @@
                   <a:srgbClr val="00E676"/>
                 </a:solidFill>
               </a:rPr>
-              <a:t>37665MW</a:t>
+              <a:t>232824MW</a:t>
             </a:r>
           </a:p>
         </p:txBody>

</xml_diff>